<commit_message>
Add captured lifecycle demonstrations to presentation
</commit_message>
<xml_diff>
--- a/ImageLab_Assessment_2_Daryn_Forman.pptx
+++ b/ImageLab_Assessment_2_Daryn_Forman.pptx
@@ -16,6 +16,9 @@
     <p:sldId id="264" r:id="rId16"/>
     <p:sldId id="265" r:id="rId17"/>
     <p:sldId id="266" r:id="rId18"/>
+    <p:sldId id="268" r:id="rId20"/>
+    <p:sldId id="269" r:id="rId21"/>
+    <p:sldId id="270" r:id="rId22"/>
     <p:sldId id="267" r:id="rId19"/>
   </p:sldIdLst>
   <p:sldSz cx="12191999" cy="6858000" type="screen4x3"/>
@@ -781,28 +784,306 @@
           <a:lstStyle/>
           <a:p>
             <a:r>
-              <a:t>My conclusion is that long polling was useful, but not because it made image transformations faster. It reduced repeated checking during quiet work and had a lower median completion-detection delay in these conditions. Frequent updates could make it send many more requests, and added latency meant more intermediate versions were skipped. The final complete snapshot was still received.</a:t>
-            </a:r>
-          </a:p>
-          <a:p>
-            <a:r>
-              <a:t>I can explain each measurement from the CSV and the matching client/server logs. I have kept unexpected findings instead of removing them to make the comparison look cleaner. Are there any questions about the implementation, measurements or recommendation?</a:t>
-            </a:r>
-          </a:p>
-          <a:p>
-            <a:r>
-              <a:t>For classroom preparation, these slides replace the narrated-video format according to the teacher’s updated instruction. They do not substitute for demonstrating or retaining evidence of the original behaviour checks. Keep the application and saved traces available for: immediate older-version response; a waiting request released by a change; a change between requests; normal 204 renewal; terminal stop for completed and failed; cancellation/mode switch with worker continuation; retry of the same job without another POST; truthful real/simulated progress; and two observers outside the single-observer experiment. A-long-1 is saved evidence of 204 renewal and successful terminal stop. The 30-run series does not establish failed-job browser stop; that path still needs live or separately saved browser evidence. Do not present code inspection as a passed runtime check.</a:t>
-            </a:r>
-          </a:p>
-          <a:p>
-            <a:r>
-              <a:t>The original brief also requires source, migration, meaningful commits, setup/experiment documentation and the Assessment 1 baseline reference. Those are separate submission evidence; this slide deck does not certify that every item is complete. No presentation time limit has been assumed.</a:t>
+              <a:t>My conclusion is that long polling was useful, but it did not make image transformations faster. It reduced repeated checking during quiet work and had a lower median completion-detection delay in these conditions. Frequent updates could create more requests, and added latency meant more intermediate versions were skipped. The final complete snapshot was still received.</a:t>
+            </a:r>
+          </a:p>
+          <a:p>
+            <a:r>
+              <a:t>The 30-row CSV and client/server logs support the experiment results. The separate demonstrations now add observed evidence of switching modes while the same job completes, Try again after a real status-connection error without another upload, and failed-job browser stopping in both modes. No source code or experiment measurements were changed to produce those captures.</a:t>
+            </a:r>
+          </a:p>
+          <a:p>
+            <a:r>
+              <a:t>I should distinguish that evidence from checks not established by these demonstrations. The retry capture used short polling. The local forwarder means the mode-switch recording does not establish backend cancellation-resource cleanup. Other original acceptance checks, such as two simultaneous observers and rejection of invalid observation parameters, still need their own saved or live evidence. A-long-1 is saved evidence of a held request, normal 204 renewal and terminal stop.</a:t>
+            </a:r>
+          </a:p>
+          <a:p>
+            <a:r>
+              <a:t>These slides follow the teacher’s updated classroom-PPT instruction rather than the original video format. Source, migration, meaningful commits, setup/experiment documentation and the Assessment 1 baseline reference remain separate submission items; this presentation does not certify all are complete. No presentation time limit has been assumed.</a:t>
+            </a:r>
+          </a:p>
+          <a:p>
+            <a:r>
+              <a:t>Questions about the implementation, measurements or demonstrations?</a:t>
             </a:r>
           </a:p>
           <a:p/>
           <a:p>
             <a:r>
-              <a:t>Evidence and preparation: Teacher brief/Version 2 acceptance checks; user instruction replacing video with classroom PPT; saved A-long-1 trace; source-code inspection.</a:t>
+              <a:t>Evidence: revised report, runs.csv, original experiment logs, and assessment2-feature-evidence/ready-to-show verified demonstrations.</a:t>
+            </a:r>
+          </a:p>
+        </p:txBody>
+      </p:sp>
+      <p:sp>
+        <p:nvSpPr>
+          <p:cNvPr id="4" name="Slide Number Placeholder 3"/>
+          <p:cNvSpPr>
+            <a:spLocks noGrp="1"/>
+          </p:cNvSpPr>
+          <p:nvPr>
+            <p:ph type="sldNum" idx="5" sz="quarter"/>
+          </p:nvPr>
+        </p:nvSpPr>
+        <p:spPr/>
+      </p:sp>
+    </p:spTree>
+  </p:cSld>
+  <p:clrMapOvr>
+    <a:masterClrMapping/>
+  </p:clrMapOvr>
+</p:notes>
+</file>
+
+<file path=ppt/notesSlides/notesSlide13.xml><?xml version="1.0" encoding="utf-8"?>
+<p:notes xmlns:a="http://schemas.openxmlformats.org/drawingml/2006/main" xmlns:p="http://schemas.openxmlformats.org/presentationml/2006/main" xmlns:r="http://schemas.openxmlformats.org/officeDocument/2006/relationships">
+  <p:cSld>
+    <p:spTree>
+      <p:nvGrpSpPr>
+        <p:cNvPr id="1" name=""/>
+        <p:cNvGrpSpPr/>
+        <p:nvPr/>
+      </p:nvGrpSpPr>
+      <p:grpSpPr>
+        <a:xfrm>
+          <a:off x="0" y="0"/>
+          <a:ext cx="0" cy="0"/>
+          <a:chOff x="0" y="0"/>
+          <a:chExt cx="0" cy="0"/>
+        </a:xfrm>
+      </p:grpSpPr>
+      <p:sp>
+        <p:nvSpPr>
+          <p:cNvPr id="2" name="Slide Image Placeholder 1"/>
+          <p:cNvSpPr>
+            <a:spLocks noGrp="1"/>
+          </p:cNvSpPr>
+          <p:nvPr>
+            <p:ph type="sldImg" idx="2"/>
+          </p:nvPr>
+        </p:nvSpPr>
+        <p:spPr/>
+      </p:sp>
+      <p:sp>
+        <p:nvSpPr>
+          <p:cNvPr id="3" name="Notes Placeholder 2"/>
+          <p:cNvSpPr>
+            <a:spLocks noGrp="1"/>
+          </p:cNvSpPr>
+          <p:nvPr>
+            <p:ph type="body" idx="3" sz="quarter"/>
+          </p:nvPr>
+        </p:nvSpPr>
+        <p:spPr/>
+        <p:txBody>
+          <a:bodyPr/>
+          <a:lstStyle/>
+          <a:p>
+            <a:r>
+              <a:t>This is now saved runtime evidence, separate from my 30 experiment runs. The animation begins after the upload, with long polling selected. Only the idle pre-upload frames were trimmed from the saved screenshot sequence. While the worker is still processing, the automation changes to short polling and then back to long polling through the page’s real mode control.</a:t>
+            </a:r>
+          </a:p>
+          <a:p>
+            <a:r>
+              <a:t>The job ID remains 0f987258-0dfd-4df2-8f3f-6886d5d71bdc. The client log records the old long poll as cancelled. The network log contains exactly one upload POST for this demonstration. The same job then reaches completed version 6 with all three variants. The observation log has 12 requests at completion and still 12 after a 6,520 ms stop check.</a:t>
+            </a:r>
+          </a:p>
+          <a:p>
+            <a:r>
+              <a:t>I can explain the animation without claiming that cancelling observation cancels work. It cancels the browser loop; the worker continues. The temporary local forwarder can retain its upstream request until the server responds, so this demonstration does not prove backend cancellation-resource cleanup. It proves the browser switch, same-job continuation and completion.</a:t>
+            </a:r>
+          </a:p>
+          <a:p>
+            <a:r>
+              <a:t>These are time-sampled native Firefox screenshots, not full-frame-rate video. The GIF keeps their capture timing and is embedded in the deck. In PowerPoint I use Slide Show to play it; the still frames and logs remain available separately.</a:t>
+            </a:r>
+          </a:p>
+          <a:p/>
+          <a:p>
+            <a:r>
+              <a:t>Evidence and preparation: ready-to-show/01-mode-switch: actions.json, client-log.json, network-log.json, server-job.log, terminal/polling-still-stopped states and verification.json.</a:t>
+            </a:r>
+          </a:p>
+        </p:txBody>
+      </p:sp>
+      <p:sp>
+        <p:nvSpPr>
+          <p:cNvPr id="4" name="Slide Number Placeholder 3"/>
+          <p:cNvSpPr>
+            <a:spLocks noGrp="1"/>
+          </p:cNvSpPr>
+          <p:nvPr>
+            <p:ph type="sldNum" idx="5" sz="quarter"/>
+          </p:nvPr>
+        </p:nvSpPr>
+        <p:spPr/>
+      </p:sp>
+    </p:spTree>
+  </p:cSld>
+  <p:clrMapOvr>
+    <a:masterClrMapping/>
+  </p:clrMapOvr>
+</p:notes>
+</file>
+
+<file path=ppt/notesSlides/notesSlide14.xml><?xml version="1.0" encoding="utf-8"?>
+<p:notes xmlns:a="http://schemas.openxmlformats.org/drawingml/2006/main" xmlns:p="http://schemas.openxmlformats.org/presentationml/2006/main" xmlns:r="http://schemas.openxmlformats.org/officeDocument/2006/relationships">
+  <p:cSld>
+    <p:spTree>
+      <p:nvGrpSpPr>
+        <p:cNvPr id="1" name=""/>
+        <p:cNvGrpSpPr/>
+        <p:nvPr/>
+      </p:nvGrpSpPr>
+      <p:grpSpPr>
+        <a:xfrm>
+          <a:off x="0" y="0"/>
+          <a:ext cx="0" cy="0"/>
+          <a:chOff x="0" y="0"/>
+          <a:chExt cx="0" cy="0"/>
+        </a:xfrm>
+      </p:grpSpPr>
+      <p:sp>
+        <p:nvSpPr>
+          <p:cNvPr id="2" name="Slide Image Placeholder 1"/>
+          <p:cNvSpPr>
+            <a:spLocks noGrp="1"/>
+          </p:cNvSpPr>
+          <p:nvPr>
+            <p:ph type="sldImg" idx="2"/>
+          </p:nvPr>
+        </p:nvSpPr>
+        <p:spPr/>
+      </p:sp>
+      <p:sp>
+        <p:nvSpPr>
+          <p:cNvPr id="3" name="Notes Placeholder 2"/>
+          <p:cNvSpPr>
+            <a:spLocks noGrp="1"/>
+          </p:cNvSpPr>
+          <p:nvPr>
+            <p:ph type="body" idx="3" sz="quarter"/>
+          </p:nvPr>
+        </p:nvSpPr>
+        <p:spPr/>
+        <p:txBody>
+          <a:bodyPr/>
+          <a:lstStyle/>
+          <a:p>
+            <a:r>
+              <a:t>I deliberately caused a genuine transport failure for a status GET. A temporary local forwarding helper closed the connection instead of returning a response. It did not invent job JSON, replace fetch, stop the worker or change application source.</a:t>
+            </a:r>
+          </a:p>
+          <a:p>
+            <a:r>
+              <a:t>The real browser showed Unable to check status and Try again. It retained the same processing snapshot at version 2 and paused checking. The automation removed the fault and clicked the actual Try again button. The error cleared, observation resumed, and job e8c3ad18-7333-40f2-b9a6-2712b29ba263 completed normally.</a:t>
+            </a:r>
+          </a:p>
+          <a:p>
+            <a:r>
+              <a:t>The network log proves there was only one POST /v1/images across this demonstration. Requests after Try again target the same job URL. The browser had 15 observation requests at completion and still 15 after a 6,487 ms stop check. Those request counts are evidence for this lifecycle check, not extra rows in the experiment CSV.</a:t>
+            </a:r>
+          </a:p>
+          <a:p>
+            <a:r>
+              <a:t>This retry demonstration used short polling. I should not describe it as a separate runtime retry check of both modes. The full-page error screenshot and native job-panel capture show the button clearly. The animation is time sampled, with only idle pre-upload frames trimmed, and plays in Slide Show. Next I show a worker failure, which is different from an observation connection error.</a:t>
+            </a:r>
+          </a:p>
+          <a:p/>
+          <a:p>
+            <a:r>
+              <a:t>Evidence and preparation: ready-to-show/02-error-and-retry: error and retry screenshots/states, actions.json, client-log.json, network-log.json, server-job.log and verification.json.</a:t>
+            </a:r>
+          </a:p>
+        </p:txBody>
+      </p:sp>
+      <p:sp>
+        <p:nvSpPr>
+          <p:cNvPr id="4" name="Slide Number Placeholder 3"/>
+          <p:cNvSpPr>
+            <a:spLocks noGrp="1"/>
+          </p:cNvSpPr>
+          <p:nvPr>
+            <p:ph type="sldNum" idx="5" sz="quarter"/>
+          </p:nvPr>
+        </p:nvSpPr>
+        <p:spPr/>
+      </p:sp>
+    </p:spTree>
+  </p:cSld>
+  <p:clrMapOvr>
+    <a:masterClrMapping/>
+  </p:clrMapOvr>
+</p:notes>
+</file>
+
+<file path=ppt/notesSlides/notesSlide15.xml><?xml version="1.0" encoding="utf-8"?>
+<p:notes xmlns:a="http://schemas.openxmlformats.org/drawingml/2006/main" xmlns:p="http://schemas.openxmlformats.org/presentationml/2006/main" xmlns:r="http://schemas.openxmlformats.org/officeDocument/2006/relationships">
+  <p:cSld>
+    <p:spTree>
+      <p:nvGrpSpPr>
+        <p:cNvPr id="1" name=""/>
+        <p:cNvGrpSpPr/>
+        <p:nvPr/>
+      </p:nvGrpSpPr>
+      <p:grpSpPr>
+        <a:xfrm>
+          <a:off x="0" y="0"/>
+          <a:ext cx="0" cy="0"/>
+          <a:chOff x="0" y="0"/>
+          <a:chExt cx="0" cy="0"/>
+        </a:xfrm>
+      </p:grpSpPr>
+      <p:sp>
+        <p:nvSpPr>
+          <p:cNvPr id="2" name="Slide Image Placeholder 1"/>
+          <p:cNvSpPr>
+            <a:spLocks noGrp="1"/>
+          </p:cNvSpPr>
+          <p:nvPr>
+            <p:ph type="sldImg" idx="2"/>
+          </p:nvPr>
+        </p:nvSpPr>
+        <p:spPr/>
+      </p:sp>
+      <p:sp>
+        <p:nvSpPr>
+          <p:cNvPr id="3" name="Notes Placeholder 2"/>
+          <p:cNvSpPr>
+            <a:spLocks noGrp="1"/>
+          </p:cNvSpPr>
+          <p:nvPr>
+            <p:ph type="body" idx="3" sz="quarter"/>
+          </p:nvPr>
+        </p:nvSpPr>
+        <p:spPr/>
+        <p:txBody>
+          <a:bodyPr/>
+          <a:lstStyle/>
+          <a:p>
+            <a:r>
+              <a:t>A connection error does not mean that image processing failed. This is a separate check where the worker itself genuinely fails.</a:t>
+            </a:r>
+          </a:p>
+          <a:p>
+            <a:r>
+              <a:t>Each demonstration began with a real valid upload and an eight-second configured worker delay. The automation temporarily renamed only that new uploaded demonstration copy in temporary storage. When the worker tried to open it, the file was missing. The unmodified worker recorded failed, a failure timestamp and the safe error message. The copy was restored afterwards; my original beach image and existing uploads were not removed.</a:t>
+            </a:r>
+          </a:p>
+          <a:p>
+            <a:r>
+              <a:t>The long-polling job is c1b2662d-d29f-4766-80c4-d86f338149f3. It reached failed version 3, displayed the safe error and Status checking stopped. Its request count stayed at 3 across a 6,345 ms stop check. The short-polling job is d05466ed-138e-497f-bc70-16410e3f4d01. Its count stayed at 10 across a 6,439 ms stop check. Both had one upload POST, zero completed variants, no completed_at timestamp and no pending browser request at the end.</a:t>
+            </a:r>
+          </a:p>
+          <a:p>
+            <a:r>
+              <a:t>Those observations now support failed-job browser stopping in both modes. They do not establish every acceptance check or every possible failure. The animations are actual time-sampled job-panel screenshots, with only idle pre-upload frames trimmed; their configuration and raw logs are saved. These fault demonstrations are outside the 30 measured runs.</a:t>
+            </a:r>
+          </a:p>
+          <a:p/>
+          <a:p>
+            <a:r>
+              <a:t>Evidence and preparation: ready-to-show/03-failure-long and 04-failure-short: terminal-failed/polling-still-stopped screenshots and states, client/network/server logs, configuration and verification.</a:t>
             </a:r>
           </a:p>
         </p:txBody>
@@ -1231,7 +1512,7 @@
           </a:p>
           <a:p>
             <a:r>
-              <a:t>This slide explains implemented code. The measured series covers successful completion, and A-long-1 demonstrates normal 204 renewal. It does not establish that every cancellation, retry or failed-job browser path was runtime-tested. Those need live or separately saved evidence.</a:t>
+              <a:t>This slide explains the implementation. The 30-run series covers successful completion and A-long-1 shows normal 204 renewal. Separate saved demonstrations on slides 12–14 now cover mode switching with worker continuation, same-job retry after a real status-connection error in short polling, and failed-job stopping in both modes. Backend cancellation cleanup and other acceptance checks are outside those captures.</a:t>
             </a:r>
           </a:p>
           <a:p/>
@@ -7105,7 +7386,7 @@
                 </a:solidFill>
                 <a:latin typeface="Liberation Sans"/>
               </a:rPr>
-              <a:t>12</a:t>
+              <a:t>15</a:t>
             </a:r>
           </a:p>
         </p:txBody>
@@ -7361,43 +7642,1975 @@
               <a:lnSpc>
                 <a:spcPct val="108000"/>
               </a:lnSpc>
-              <a:spcBef>
-                <a:spcPts val="0"/>
-              </a:spcBef>
-              <a:spcAft>
-                <a:spcPts val="0"/>
-              </a:spcAft>
-            </a:pPr>
-            <a:r>
-              <a:rPr sz="2100" b="0">
+            </a:pPr>
+            <a:r>
+              <a:rPr sz="2100">
                 <a:solidFill>
                   <a:srgbClr val="304B53"/>
                 </a:solidFill>
                 <a:latin typeface="Liberation Sans"/>
               </a:rPr>
-              <a:t>Keep live evidence available: held request, 204 renewal, cancel/retry,</a:t>
-            </a:r>
-          </a:p>
-          <a:p>
-            <a:pPr>
-              <a:lnSpc>
-                <a:spcPct val="108000"/>
-              </a:lnSpc>
-              <a:spcBef>
-                <a:spcPts val="0"/>
-              </a:spcBef>
-              <a:spcAft>
-                <a:spcPts val="0"/>
-              </a:spcAft>
-            </a:pPr>
-            <a:r>
-              <a:rPr sz="2100" b="0">
+              <a:t>Saved demonstrations cover mode switching, retry and failed-job stop.</a:t>
+            </a:r>
+          </a:p>
+          <a:p>
+            <a:pPr>
+              <a:lnSpc>
+                <a:spcPct val="108000"/>
+              </a:lnSpc>
+            </a:pPr>
+            <a:r>
+              <a:rPr sz="2100">
                 <a:solidFill>
                   <a:srgbClr val="304B53"/>
                 </a:solidFill>
                 <a:latin typeface="Liberation Sans"/>
               </a:rPr>
-              <a:t>failed-job stop and two observers. Slides do not prove those checks.</a:t>
+              <a:t>Keep the app or separate traces ready for other checks, including two observers.</a:t>
+            </a:r>
+          </a:p>
+        </p:txBody>
+      </p:sp>
+    </p:spTree>
+  </p:cSld>
+  <p:clrMapOvr>
+    <a:masterClrMapping/>
+  </p:clrMapOvr>
+</p:sld>
+</file>
+
+<file path=ppt/slides/slide13.xml><?xml version="1.0" encoding="utf-8"?>
+<p:sld xmlns:a="http://schemas.openxmlformats.org/drawingml/2006/main" xmlns:p="http://schemas.openxmlformats.org/presentationml/2006/main" xmlns:r="http://schemas.openxmlformats.org/officeDocument/2006/relationships">
+  <p:cSld>
+    <p:bg>
+      <p:bgPr>
+        <a:solidFill>
+          <a:srgbClr val="FFFFFF"/>
+        </a:solidFill>
+        <a:effectLst/>
+      </p:bgPr>
+    </p:bg>
+    <p:spTree>
+      <p:nvGrpSpPr>
+        <p:cNvPr id="1" name=""/>
+        <p:cNvGrpSpPr/>
+        <p:nvPr/>
+      </p:nvGrpSpPr>
+      <p:grpSpPr/>
+      <p:sp>
+        <p:nvSpPr>
+          <p:cNvPr id="2" name="Rectangle 1"/>
+          <p:cNvSpPr/>
+          <p:nvPr/>
+        </p:nvSpPr>
+        <p:spPr>
+          <a:xfrm>
+            <a:off x="475488" y="438912"/>
+            <a:ext cx="64008" cy="448056"/>
+          </a:xfrm>
+          <a:prstGeom prst="rect">
+            <a:avLst/>
+          </a:prstGeom>
+          <a:solidFill>
+            <a:srgbClr val="008C91"/>
+          </a:solidFill>
+          <a:ln>
+            <a:noFill/>
+          </a:ln>
+          <a:effectLst/>
+        </p:spPr>
+        <p:style>
+          <a:lnRef idx="1">
+            <a:schemeClr val="accent1"/>
+          </a:lnRef>
+          <a:fillRef idx="3">
+            <a:schemeClr val="accent1"/>
+          </a:fillRef>
+          <a:effectRef idx="2">
+            <a:schemeClr val="accent1"/>
+          </a:effectRef>
+          <a:fontRef idx="minor">
+            <a:schemeClr val="lt1"/>
+          </a:fontRef>
+        </p:style>
+        <p:txBody>
+          <a:bodyPr rtlCol="0" anchor="ctr"/>
+          <a:lstStyle/>
+          <a:p>
+            <a:pPr algn="ctr"/>
+          </a:p>
+        </p:txBody>
+      </p:sp>
+      <p:sp>
+        <p:nvSpPr>
+          <p:cNvPr id="3" name="Text Demonstration: switch modes, kee"/>
+          <p:cNvSpPr txBox="1"/>
+          <p:nvPr/>
+        </p:nvSpPr>
+        <p:spPr>
+          <a:xfrm>
+            <a:off x="694944" y="374904"/>
+            <a:ext cx="10972800" cy="521207"/>
+          </a:xfrm>
+          <a:prstGeom prst="rect">
+            <a:avLst/>
+          </a:prstGeom>
+          <a:noFill/>
+        </p:spPr>
+        <p:txBody>
+          <a:bodyPr wrap="square" lIns="9144" rIns="9144" tIns="0" bIns="0" anchor="t">
+            <a:spAutoFit/>
+          </a:bodyPr>
+          <a:lstStyle/>
+          <a:p>
+            <a:pPr>
+              <a:lnSpc>
+                <a:spcPct val="108000"/>
+              </a:lnSpc>
+              <a:spcBef>
+                <a:spcPts val="0"/>
+              </a:spcBef>
+              <a:spcAft>
+                <a:spcPts val="0"/>
+              </a:spcAft>
+            </a:pPr>
+            <a:r>
+              <a:rPr sz="3300" b="1">
+                <a:solidFill>
+                  <a:srgbClr val="17363D"/>
+                </a:solidFill>
+                <a:latin typeface="Liberation Sans"/>
+              </a:rPr>
+              <a:t>Demonstration: switch modes, keep the job</a:t>
+            </a:r>
+          </a:p>
+        </p:txBody>
+      </p:sp>
+      <p:sp>
+        <p:nvSpPr>
+          <p:cNvPr id="4" name="Text Daryn Forman  |  ImageLab Assess"/>
+          <p:cNvSpPr txBox="1"/>
+          <p:nvPr/>
+        </p:nvSpPr>
+        <p:spPr>
+          <a:xfrm>
+            <a:off x="521207" y="6537960"/>
+            <a:ext cx="8229600" cy="173736"/>
+          </a:xfrm>
+          <a:prstGeom prst="rect">
+            <a:avLst/>
+          </a:prstGeom>
+          <a:noFill/>
+        </p:spPr>
+        <p:txBody>
+          <a:bodyPr wrap="square" lIns="9144" rIns="9144" tIns="0" bIns="0" anchor="t">
+            <a:spAutoFit/>
+          </a:bodyPr>
+          <a:lstStyle/>
+          <a:p>
+            <a:pPr>
+              <a:lnSpc>
+                <a:spcPct val="108000"/>
+              </a:lnSpc>
+              <a:spcBef>
+                <a:spcPts val="0"/>
+              </a:spcBef>
+              <a:spcAft>
+                <a:spcPts val="0"/>
+              </a:spcAft>
+            </a:pPr>
+            <a:r>
+              <a:rPr sz="1100" b="0">
+                <a:solidFill>
+                  <a:srgbClr val="62757A"/>
+                </a:solidFill>
+                <a:latin typeface="Liberation Sans"/>
+              </a:rPr>
+              <a:t>Daryn Forman  |  ImageLab Assessment 2  |  Saved application evidence</a:t>
+            </a:r>
+          </a:p>
+        </p:txBody>
+      </p:sp>
+      <p:sp>
+        <p:nvSpPr>
+          <p:cNvPr id="5" name="Text 13"/>
+          <p:cNvSpPr txBox="1"/>
+          <p:nvPr/>
+        </p:nvSpPr>
+        <p:spPr>
+          <a:xfrm>
+            <a:off x="11082528" y="6492240"/>
+            <a:ext cx="576072" cy="228600"/>
+          </a:xfrm>
+          <a:prstGeom prst="rect">
+            <a:avLst/>
+          </a:prstGeom>
+          <a:noFill/>
+        </p:spPr>
+        <p:txBody>
+          <a:bodyPr wrap="square" lIns="9144" rIns="9144" tIns="0" bIns="0" anchor="t">
+            <a:spAutoFit/>
+          </a:bodyPr>
+          <a:lstStyle/>
+          <a:p>
+            <a:pPr algn="r">
+              <a:lnSpc>
+                <a:spcPct val="108000"/>
+              </a:lnSpc>
+              <a:spcBef>
+                <a:spcPts val="0"/>
+              </a:spcBef>
+              <a:spcAft>
+                <a:spcPts val="0"/>
+              </a:spcAft>
+            </a:pPr>
+            <a:r>
+              <a:rPr sz="1300" b="1">
+                <a:solidFill>
+                  <a:srgbClr val="008C91"/>
+                </a:solidFill>
+                <a:latin typeface="Liberation Sans"/>
+              </a:rPr>
+              <a:t>12</a:t>
+            </a:r>
+          </a:p>
+        </p:txBody>
+      </p:sp>
+      <p:sp>
+        <p:nvSpPr>
+          <p:cNvPr id="6" name="Text Real browser capture: long → sho"/>
+          <p:cNvSpPr txBox="1"/>
+          <p:nvPr/>
+        </p:nvSpPr>
+        <p:spPr>
+          <a:xfrm>
+            <a:off x="548640" y="1051560"/>
+            <a:ext cx="11064240" cy="411480"/>
+          </a:xfrm>
+          <a:prstGeom prst="rect">
+            <a:avLst/>
+          </a:prstGeom>
+          <a:noFill/>
+        </p:spPr>
+        <p:txBody>
+          <a:bodyPr wrap="square" lIns="9144" rIns="9144" tIns="0" bIns="0" anchor="t">
+            <a:spAutoFit/>
+          </a:bodyPr>
+          <a:lstStyle/>
+          <a:p>
+            <a:pPr>
+              <a:lnSpc>
+                <a:spcPct val="108000"/>
+              </a:lnSpc>
+              <a:spcBef>
+                <a:spcPts val="0"/>
+              </a:spcBef>
+              <a:spcAft>
+                <a:spcPts val="0"/>
+              </a:spcAft>
+            </a:pPr>
+            <a:r>
+              <a:rPr sz="2400" b="0">
+                <a:solidFill>
+                  <a:srgbClr val="304B53"/>
+                </a:solidFill>
+                <a:latin typeface="Liberation Sans"/>
+              </a:rPr>
+              <a:t>Real browser capture: long → short → long, while processing continues.</a:t>
+            </a:r>
+          </a:p>
+        </p:txBody>
+      </p:sp>
+      <p:pic>
+        <p:nvPicPr>
+          <p:cNvPr id="7" name="Picture 6" descr="01-mode-switch-presentation.gif"/>
+          <p:cNvPicPr>
+            <a:picLocks noChangeAspect="1"/>
+          </p:cNvPicPr>
+          <p:nvPr/>
+        </p:nvPicPr>
+        <p:blipFill>
+          <a:blip r:embed="rId2"/>
+          <a:stretch>
+            <a:fillRect/>
+          </a:stretch>
+        </p:blipFill>
+        <p:spPr>
+          <a:xfrm>
+            <a:off x="1072210" y="1746504"/>
+            <a:ext cx="3844899" cy="4498848"/>
+          </a:xfrm>
+          <a:prstGeom prst="rect">
+            <a:avLst/>
+          </a:prstGeom>
+        </p:spPr>
+      </p:pic>
+      <p:sp>
+        <p:nvSpPr>
+          <p:cNvPr id="8" name="Text Same job throughout"/>
+          <p:cNvSpPr txBox="1"/>
+          <p:nvPr/>
+        </p:nvSpPr>
+        <p:spPr>
+          <a:xfrm>
+            <a:off x="5806440" y="1828800"/>
+            <a:ext cx="5577840" cy="429768"/>
+          </a:xfrm>
+          <a:prstGeom prst="rect">
+            <a:avLst/>
+          </a:prstGeom>
+          <a:noFill/>
+        </p:spPr>
+        <p:txBody>
+          <a:bodyPr wrap="square" lIns="9144" rIns="9144" tIns="0" bIns="0" anchor="t">
+            <a:spAutoFit/>
+          </a:bodyPr>
+          <a:lstStyle/>
+          <a:p>
+            <a:pPr>
+              <a:lnSpc>
+                <a:spcPct val="108000"/>
+              </a:lnSpc>
+              <a:spcBef>
+                <a:spcPts val="0"/>
+              </a:spcBef>
+              <a:spcAft>
+                <a:spcPts val="0"/>
+              </a:spcAft>
+            </a:pPr>
+            <a:r>
+              <a:rPr sz="2700" b="1">
+                <a:solidFill>
+                  <a:srgbClr val="008C91"/>
+                </a:solidFill>
+                <a:latin typeface="Liberation Sans"/>
+              </a:rPr>
+              <a:t>Same job throughout</a:t>
+            </a:r>
+          </a:p>
+        </p:txBody>
+      </p:sp>
+      <p:sp>
+        <p:nvSpPr>
+          <p:cNvPr id="9" name="Text Job 0f987258…&#10;Same ID across bot"/>
+          <p:cNvSpPr txBox="1"/>
+          <p:nvPr/>
+        </p:nvSpPr>
+        <p:spPr>
+          <a:xfrm>
+            <a:off x="5806440" y="2386584"/>
+            <a:ext cx="5577840" cy="777240"/>
+          </a:xfrm>
+          <a:prstGeom prst="rect">
+            <a:avLst/>
+          </a:prstGeom>
+          <a:noFill/>
+        </p:spPr>
+        <p:txBody>
+          <a:bodyPr wrap="square" lIns="9144" rIns="9144" tIns="0" bIns="0" anchor="t">
+            <a:spAutoFit/>
+          </a:bodyPr>
+          <a:lstStyle/>
+          <a:p>
+            <a:pPr>
+              <a:lnSpc>
+                <a:spcPct val="108000"/>
+              </a:lnSpc>
+              <a:spcBef>
+                <a:spcPts val="0"/>
+              </a:spcBef>
+              <a:spcAft>
+                <a:spcPts val="0"/>
+              </a:spcAft>
+            </a:pPr>
+            <a:r>
+              <a:rPr sz="2400" b="0">
+                <a:solidFill>
+                  <a:srgbClr val="304B53"/>
+                </a:solidFill>
+                <a:latin typeface="Liberation Sans"/>
+              </a:rPr>
+              <a:t>Job 0f987258…</a:t>
+            </a:r>
+          </a:p>
+          <a:p>
+            <a:pPr>
+              <a:lnSpc>
+                <a:spcPct val="108000"/>
+              </a:lnSpc>
+              <a:spcBef>
+                <a:spcPts val="0"/>
+              </a:spcBef>
+              <a:spcAft>
+                <a:spcPts val="0"/>
+              </a:spcAft>
+            </a:pPr>
+            <a:r>
+              <a:rPr sz="2400" b="0">
+                <a:solidFill>
+                  <a:srgbClr val="304B53"/>
+                </a:solidFill>
+                <a:latin typeface="Liberation Sans"/>
+              </a:rPr>
+              <a:t>Same ID across both switches.</a:t>
+            </a:r>
+          </a:p>
+        </p:txBody>
+      </p:sp>
+      <p:sp>
+        <p:nvSpPr>
+          <p:cNvPr id="10" name="Text One upload, three real variants"/>
+          <p:cNvSpPr txBox="1"/>
+          <p:nvPr/>
+        </p:nvSpPr>
+        <p:spPr>
+          <a:xfrm>
+            <a:off x="5806440" y="3291840"/>
+            <a:ext cx="5577840" cy="429768"/>
+          </a:xfrm>
+          <a:prstGeom prst="rect">
+            <a:avLst/>
+          </a:prstGeom>
+          <a:noFill/>
+        </p:spPr>
+        <p:txBody>
+          <a:bodyPr wrap="square" lIns="9144" rIns="9144" tIns="0" bIns="0" anchor="t">
+            <a:spAutoFit/>
+          </a:bodyPr>
+          <a:lstStyle/>
+          <a:p>
+            <a:pPr>
+              <a:lnSpc>
+                <a:spcPct val="108000"/>
+              </a:lnSpc>
+              <a:spcBef>
+                <a:spcPts val="0"/>
+              </a:spcBef>
+              <a:spcAft>
+                <a:spcPts val="0"/>
+              </a:spcAft>
+            </a:pPr>
+            <a:r>
+              <a:rPr sz="2700" b="1">
+                <a:solidFill>
+                  <a:srgbClr val="008C91"/>
+                </a:solidFill>
+                <a:latin typeface="Liberation Sans"/>
+              </a:rPr>
+              <a:t>One upload, three real variants</a:t>
+            </a:r>
+          </a:p>
+        </p:txBody>
+      </p:sp>
+      <p:sp>
+        <p:nvSpPr>
+          <p:cNvPr id="11" name="Text Network log: 1 POST.&#10;Same job co"/>
+          <p:cNvSpPr txBox="1"/>
+          <p:nvPr/>
+        </p:nvSpPr>
+        <p:spPr>
+          <a:xfrm>
+            <a:off x="5806440" y="3849624"/>
+            <a:ext cx="5577840" cy="777240"/>
+          </a:xfrm>
+          <a:prstGeom prst="rect">
+            <a:avLst/>
+          </a:prstGeom>
+          <a:noFill/>
+        </p:spPr>
+        <p:txBody>
+          <a:bodyPr wrap="square" lIns="9144" rIns="9144" tIns="0" bIns="0" anchor="t">
+            <a:spAutoFit/>
+          </a:bodyPr>
+          <a:lstStyle/>
+          <a:p>
+            <a:pPr>
+              <a:lnSpc>
+                <a:spcPct val="108000"/>
+              </a:lnSpc>
+              <a:spcBef>
+                <a:spcPts val="0"/>
+              </a:spcBef>
+              <a:spcAft>
+                <a:spcPts val="0"/>
+              </a:spcAft>
+            </a:pPr>
+            <a:r>
+              <a:rPr sz="2400" b="0">
+                <a:solidFill>
+                  <a:srgbClr val="304B53"/>
+                </a:solidFill>
+                <a:latin typeface="Liberation Sans"/>
+              </a:rPr>
+              <a:t>Network log: 1 POST.</a:t>
+            </a:r>
+          </a:p>
+          <a:p>
+            <a:pPr>
+              <a:lnSpc>
+                <a:spcPct val="108000"/>
+              </a:lnSpc>
+              <a:spcBef>
+                <a:spcPts val="0"/>
+              </a:spcBef>
+              <a:spcAft>
+                <a:spcPts val="0"/>
+              </a:spcAft>
+            </a:pPr>
+            <a:r>
+              <a:rPr sz="2400" b="0">
+                <a:solidFill>
+                  <a:srgbClr val="304B53"/>
+                </a:solidFill>
+                <a:latin typeface="Liberation Sans"/>
+              </a:rPr>
+              <a:t>Same job completes with 3 variants.</a:t>
+            </a:r>
+          </a:p>
+        </p:txBody>
+      </p:sp>
+      <p:sp>
+        <p:nvSpPr>
+          <p:cNvPr id="12" name="Text Old observation cancelled"/>
+          <p:cNvSpPr txBox="1"/>
+          <p:nvPr/>
+        </p:nvSpPr>
+        <p:spPr>
+          <a:xfrm>
+            <a:off x="5806440" y="4754880"/>
+            <a:ext cx="5577840" cy="429768"/>
+          </a:xfrm>
+          <a:prstGeom prst="rect">
+            <a:avLst/>
+          </a:prstGeom>
+          <a:noFill/>
+        </p:spPr>
+        <p:txBody>
+          <a:bodyPr wrap="square" lIns="9144" rIns="9144" tIns="0" bIns="0" anchor="t">
+            <a:spAutoFit/>
+          </a:bodyPr>
+          <a:lstStyle/>
+          <a:p>
+            <a:pPr>
+              <a:lnSpc>
+                <a:spcPct val="108000"/>
+              </a:lnSpc>
+              <a:spcBef>
+                <a:spcPts val="0"/>
+              </a:spcBef>
+              <a:spcAft>
+                <a:spcPts val="0"/>
+              </a:spcAft>
+            </a:pPr>
+            <a:r>
+              <a:rPr sz="2700" b="1">
+                <a:solidFill>
+                  <a:srgbClr val="008C91"/>
+                </a:solidFill>
+                <a:latin typeface="Liberation Sans"/>
+              </a:rPr>
+              <a:t>Old observation cancelled</a:t>
+            </a:r>
+          </a:p>
+        </p:txBody>
+      </p:sp>
+      <p:sp>
+        <p:nvSpPr>
+          <p:cNvPr id="13" name="Text Cancelled request recorded.&#10;No l"/>
+          <p:cNvSpPr txBox="1"/>
+          <p:nvPr/>
+        </p:nvSpPr>
+        <p:spPr>
+          <a:xfrm>
+            <a:off x="5806440" y="5312664"/>
+            <a:ext cx="5577840" cy="777240"/>
+          </a:xfrm>
+          <a:prstGeom prst="rect">
+            <a:avLst/>
+          </a:prstGeom>
+          <a:noFill/>
+        </p:spPr>
+        <p:txBody>
+          <a:bodyPr wrap="square" lIns="9144" rIns="9144" tIns="0" bIns="0" anchor="t">
+            <a:spAutoFit/>
+          </a:bodyPr>
+          <a:lstStyle/>
+          <a:p>
+            <a:pPr>
+              <a:lnSpc>
+                <a:spcPct val="108000"/>
+              </a:lnSpc>
+              <a:spcBef>
+                <a:spcPts val="0"/>
+              </a:spcBef>
+              <a:spcAft>
+                <a:spcPts val="0"/>
+              </a:spcAft>
+            </a:pPr>
+            <a:r>
+              <a:rPr sz="2400" b="0">
+                <a:solidFill>
+                  <a:srgbClr val="304B53"/>
+                </a:solidFill>
+                <a:latin typeface="Liberation Sans"/>
+              </a:rPr>
+              <a:t>Cancelled request recorded.</a:t>
+            </a:r>
+          </a:p>
+          <a:p>
+            <a:pPr>
+              <a:lnSpc>
+                <a:spcPct val="108000"/>
+              </a:lnSpc>
+              <a:spcBef>
+                <a:spcPts val="0"/>
+              </a:spcBef>
+              <a:spcAft>
+                <a:spcPts val="0"/>
+              </a:spcAft>
+            </a:pPr>
+            <a:r>
+              <a:rPr sz="2400" b="0">
+                <a:solidFill>
+                  <a:srgbClr val="304B53"/>
+                </a:solidFill>
+                <a:latin typeface="Liberation Sans"/>
+              </a:rPr>
+              <a:t>No later GETs in the stop check.</a:t>
+            </a:r>
+          </a:p>
+        </p:txBody>
+      </p:sp>
+      <p:sp>
+        <p:nvSpPr>
+          <p:cNvPr id="14" name="Text Animated screenshots: play in Sl"/>
+          <p:cNvSpPr txBox="1"/>
+          <p:nvPr/>
+        </p:nvSpPr>
+        <p:spPr>
+          <a:xfrm>
+            <a:off x="566928" y="6318504"/>
+            <a:ext cx="10972800" cy="201168"/>
+          </a:xfrm>
+          <a:prstGeom prst="rect">
+            <a:avLst/>
+          </a:prstGeom>
+          <a:noFill/>
+        </p:spPr>
+        <p:txBody>
+          <a:bodyPr wrap="square" lIns="9144" rIns="9144" tIns="0" bIns="0" anchor="t">
+            <a:spAutoFit/>
+          </a:bodyPr>
+          <a:lstStyle/>
+          <a:p>
+            <a:pPr>
+              <a:lnSpc>
+                <a:spcPct val="108000"/>
+              </a:lnSpc>
+              <a:spcBef>
+                <a:spcPts val="0"/>
+              </a:spcBef>
+              <a:spcAft>
+                <a:spcPts val="0"/>
+              </a:spcAft>
+            </a:pPr>
+            <a:r>
+              <a:rPr sz="1300" b="0">
+                <a:solidFill>
+                  <a:srgbClr val="62757A"/>
+                </a:solidFill>
+                <a:latin typeface="Liberation Sans"/>
+              </a:rPr>
+              <a:t>Animated screenshots: play in Slide Show. Starts after upload; raw frames, timestamps and logs are saved.</a:t>
+            </a:r>
+          </a:p>
+        </p:txBody>
+      </p:sp>
+    </p:spTree>
+  </p:cSld>
+  <p:clrMapOvr>
+    <a:masterClrMapping/>
+  </p:clrMapOvr>
+</p:sld>
+</file>
+
+<file path=ppt/slides/slide14.xml><?xml version="1.0" encoding="utf-8"?>
+<p:sld xmlns:a="http://schemas.openxmlformats.org/drawingml/2006/main" xmlns:p="http://schemas.openxmlformats.org/presentationml/2006/main" xmlns:r="http://schemas.openxmlformats.org/officeDocument/2006/relationships">
+  <p:cSld>
+    <p:bg>
+      <p:bgPr>
+        <a:solidFill>
+          <a:srgbClr val="FFFFFF"/>
+        </a:solidFill>
+        <a:effectLst/>
+      </p:bgPr>
+    </p:bg>
+    <p:spTree>
+      <p:nvGrpSpPr>
+        <p:cNvPr id="1" name=""/>
+        <p:cNvGrpSpPr/>
+        <p:nvPr/>
+      </p:nvGrpSpPr>
+      <p:grpSpPr/>
+      <p:sp>
+        <p:nvSpPr>
+          <p:cNvPr id="2" name="Rectangle 1"/>
+          <p:cNvSpPr/>
+          <p:nvPr/>
+        </p:nvSpPr>
+        <p:spPr>
+          <a:xfrm>
+            <a:off x="475488" y="438912"/>
+            <a:ext cx="64008" cy="448056"/>
+          </a:xfrm>
+          <a:prstGeom prst="rect">
+            <a:avLst/>
+          </a:prstGeom>
+          <a:solidFill>
+            <a:srgbClr val="008C91"/>
+          </a:solidFill>
+          <a:ln>
+            <a:noFill/>
+          </a:ln>
+          <a:effectLst/>
+        </p:spPr>
+        <p:style>
+          <a:lnRef idx="1">
+            <a:schemeClr val="accent1"/>
+          </a:lnRef>
+          <a:fillRef idx="3">
+            <a:schemeClr val="accent1"/>
+          </a:fillRef>
+          <a:effectRef idx="2">
+            <a:schemeClr val="accent1"/>
+          </a:effectRef>
+          <a:fontRef idx="minor">
+            <a:schemeClr val="lt1"/>
+          </a:fontRef>
+        </p:style>
+        <p:txBody>
+          <a:bodyPr rtlCol="0" anchor="ctr"/>
+          <a:lstStyle/>
+          <a:p>
+            <a:pPr algn="ctr"/>
+          </a:p>
+        </p:txBody>
+      </p:sp>
+      <p:sp>
+        <p:nvSpPr>
+          <p:cNvPr id="3" name="Text Demonstration: error, Try again,"/>
+          <p:cNvSpPr txBox="1"/>
+          <p:nvPr/>
+        </p:nvSpPr>
+        <p:spPr>
+          <a:xfrm>
+            <a:off x="694944" y="374904"/>
+            <a:ext cx="10972800" cy="521207"/>
+          </a:xfrm>
+          <a:prstGeom prst="rect">
+            <a:avLst/>
+          </a:prstGeom>
+          <a:noFill/>
+        </p:spPr>
+        <p:txBody>
+          <a:bodyPr wrap="square" lIns="9144" rIns="9144" tIns="0" bIns="0" anchor="t">
+            <a:spAutoFit/>
+          </a:bodyPr>
+          <a:lstStyle/>
+          <a:p>
+            <a:pPr>
+              <a:lnSpc>
+                <a:spcPct val="108000"/>
+              </a:lnSpc>
+              <a:spcBef>
+                <a:spcPts val="0"/>
+              </a:spcBef>
+              <a:spcAft>
+                <a:spcPts val="0"/>
+              </a:spcAft>
+            </a:pPr>
+            <a:r>
+              <a:rPr sz="3300" b="1">
+                <a:solidFill>
+                  <a:srgbClr val="17363D"/>
+                </a:solidFill>
+                <a:latin typeface="Liberation Sans"/>
+              </a:rPr>
+              <a:t>Demonstration: error, Try again, same job</a:t>
+            </a:r>
+          </a:p>
+        </p:txBody>
+      </p:sp>
+      <p:sp>
+        <p:nvSpPr>
+          <p:cNvPr id="4" name="Text Daryn Forman  |  ImageLab Assess"/>
+          <p:cNvSpPr txBox="1"/>
+          <p:nvPr/>
+        </p:nvSpPr>
+        <p:spPr>
+          <a:xfrm>
+            <a:off x="521207" y="6537960"/>
+            <a:ext cx="8229600" cy="173736"/>
+          </a:xfrm>
+          <a:prstGeom prst="rect">
+            <a:avLst/>
+          </a:prstGeom>
+          <a:noFill/>
+        </p:spPr>
+        <p:txBody>
+          <a:bodyPr wrap="square" lIns="9144" rIns="9144" tIns="0" bIns="0" anchor="t">
+            <a:spAutoFit/>
+          </a:bodyPr>
+          <a:lstStyle/>
+          <a:p>
+            <a:pPr>
+              <a:lnSpc>
+                <a:spcPct val="108000"/>
+              </a:lnSpc>
+              <a:spcBef>
+                <a:spcPts val="0"/>
+              </a:spcBef>
+              <a:spcAft>
+                <a:spcPts val="0"/>
+              </a:spcAft>
+            </a:pPr>
+            <a:r>
+              <a:rPr sz="1100" b="0">
+                <a:solidFill>
+                  <a:srgbClr val="62757A"/>
+                </a:solidFill>
+                <a:latin typeface="Liberation Sans"/>
+              </a:rPr>
+              <a:t>Daryn Forman  |  ImageLab Assessment 2  |  Saved application evidence</a:t>
+            </a:r>
+          </a:p>
+        </p:txBody>
+      </p:sp>
+      <p:sp>
+        <p:nvSpPr>
+          <p:cNvPr id="5" name="Text 14"/>
+          <p:cNvSpPr txBox="1"/>
+          <p:nvPr/>
+        </p:nvSpPr>
+        <p:spPr>
+          <a:xfrm>
+            <a:off x="11082528" y="6492240"/>
+            <a:ext cx="576072" cy="228600"/>
+          </a:xfrm>
+          <a:prstGeom prst="rect">
+            <a:avLst/>
+          </a:prstGeom>
+          <a:noFill/>
+        </p:spPr>
+        <p:txBody>
+          <a:bodyPr wrap="square" lIns="9144" rIns="9144" tIns="0" bIns="0" anchor="t">
+            <a:spAutoFit/>
+          </a:bodyPr>
+          <a:lstStyle/>
+          <a:p>
+            <a:pPr algn="r">
+              <a:lnSpc>
+                <a:spcPct val="108000"/>
+              </a:lnSpc>
+              <a:spcBef>
+                <a:spcPts val="0"/>
+              </a:spcBef>
+              <a:spcAft>
+                <a:spcPts val="0"/>
+              </a:spcAft>
+            </a:pPr>
+            <a:r>
+              <a:rPr sz="1300" b="1">
+                <a:solidFill>
+                  <a:srgbClr val="008C91"/>
+                </a:solidFill>
+                <a:latin typeface="Liberation Sans"/>
+              </a:rPr>
+              <a:t>13</a:t>
+            </a:r>
+          </a:p>
+        </p:txBody>
+      </p:sp>
+      <p:sp>
+        <p:nvSpPr>
+          <p:cNvPr id="6" name="Text A real failed status fetch pause"/>
+          <p:cNvSpPr txBox="1"/>
+          <p:nvPr/>
+        </p:nvSpPr>
+        <p:spPr>
+          <a:xfrm>
+            <a:off x="548640" y="1051560"/>
+            <a:ext cx="11064240" cy="411480"/>
+          </a:xfrm>
+          <a:prstGeom prst="rect">
+            <a:avLst/>
+          </a:prstGeom>
+          <a:noFill/>
+        </p:spPr>
+        <p:txBody>
+          <a:bodyPr wrap="square" lIns="9144" rIns="9144" tIns="0" bIns="0" anchor="t">
+            <a:spAutoFit/>
+          </a:bodyPr>
+          <a:lstStyle/>
+          <a:p>
+            <a:pPr>
+              <a:lnSpc>
+                <a:spcPct val="108000"/>
+              </a:lnSpc>
+              <a:spcBef>
+                <a:spcPts val="0"/>
+              </a:spcBef>
+              <a:spcAft>
+                <a:spcPts val="0"/>
+              </a:spcAft>
+            </a:pPr>
+            <a:r>
+              <a:rPr sz="2400" b="0">
+                <a:solidFill>
+                  <a:srgbClr val="304B53"/>
+                </a:solidFill>
+                <a:latin typeface="Liberation Sans"/>
+              </a:rPr>
+              <a:t>A real failed status fetch pauses observation; Try again resumes it.</a:t>
+            </a:r>
+          </a:p>
+        </p:txBody>
+      </p:sp>
+      <p:pic>
+        <p:nvPicPr>
+          <p:cNvPr id="7" name="Picture 6" descr="02-error-and-retry-presentation.gif"/>
+          <p:cNvPicPr>
+            <a:picLocks noChangeAspect="1"/>
+          </p:cNvPicPr>
+          <p:nvPr/>
+        </p:nvPicPr>
+        <p:blipFill>
+          <a:blip r:embed="rId2"/>
+          <a:stretch>
+            <a:fillRect/>
+          </a:stretch>
+        </p:blipFill>
+        <p:spPr>
+          <a:xfrm>
+            <a:off x="1448577" y="1746504"/>
+            <a:ext cx="3092165" cy="4498848"/>
+          </a:xfrm>
+          <a:prstGeom prst="rect">
+            <a:avLst/>
+          </a:prstGeom>
+        </p:spPr>
+      </p:pic>
+      <p:sp>
+        <p:nvSpPr>
+          <p:cNvPr id="8" name="Text Last known state preserved"/>
+          <p:cNvSpPr txBox="1"/>
+          <p:nvPr/>
+        </p:nvSpPr>
+        <p:spPr>
+          <a:xfrm>
+            <a:off x="5806440" y="1828800"/>
+            <a:ext cx="5577840" cy="429768"/>
+          </a:xfrm>
+          <a:prstGeom prst="rect">
+            <a:avLst/>
+          </a:prstGeom>
+          <a:noFill/>
+        </p:spPr>
+        <p:txBody>
+          <a:bodyPr wrap="square" lIns="9144" rIns="9144" tIns="0" bIns="0" anchor="t">
+            <a:spAutoFit/>
+          </a:bodyPr>
+          <a:lstStyle/>
+          <a:p>
+            <a:pPr>
+              <a:lnSpc>
+                <a:spcPct val="108000"/>
+              </a:lnSpc>
+              <a:spcBef>
+                <a:spcPts val="0"/>
+              </a:spcBef>
+              <a:spcAft>
+                <a:spcPts val="0"/>
+              </a:spcAft>
+            </a:pPr>
+            <a:r>
+              <a:rPr sz="2700" b="1">
+                <a:solidFill>
+                  <a:srgbClr val="008C91"/>
+                </a:solidFill>
+                <a:latin typeface="Liberation Sans"/>
+              </a:rPr>
+              <a:t>Last known state preserved</a:t>
+            </a:r>
+          </a:p>
+        </p:txBody>
+      </p:sp>
+      <p:sp>
+        <p:nvSpPr>
+          <p:cNvPr id="9" name="Text Error panel appears.&#10;Job stays p"/>
+          <p:cNvSpPr txBox="1"/>
+          <p:nvPr/>
+        </p:nvSpPr>
+        <p:spPr>
+          <a:xfrm>
+            <a:off x="5806440" y="2386584"/>
+            <a:ext cx="5577840" cy="777240"/>
+          </a:xfrm>
+          <a:prstGeom prst="rect">
+            <a:avLst/>
+          </a:prstGeom>
+          <a:noFill/>
+        </p:spPr>
+        <p:txBody>
+          <a:bodyPr wrap="square" lIns="9144" rIns="9144" tIns="0" bIns="0" anchor="t">
+            <a:spAutoFit/>
+          </a:bodyPr>
+          <a:lstStyle/>
+          <a:p>
+            <a:pPr>
+              <a:lnSpc>
+                <a:spcPct val="108000"/>
+              </a:lnSpc>
+              <a:spcBef>
+                <a:spcPts val="0"/>
+              </a:spcBef>
+              <a:spcAft>
+                <a:spcPts val="0"/>
+              </a:spcAft>
+            </a:pPr>
+            <a:r>
+              <a:rPr sz="2400" b="0">
+                <a:solidFill>
+                  <a:srgbClr val="304B53"/>
+                </a:solidFill>
+                <a:latin typeface="Liberation Sans"/>
+              </a:rPr>
+              <a:t>Error panel appears.</a:t>
+            </a:r>
+          </a:p>
+          <a:p>
+            <a:pPr>
+              <a:lnSpc>
+                <a:spcPct val="108000"/>
+              </a:lnSpc>
+              <a:spcBef>
+                <a:spcPts val="0"/>
+              </a:spcBef>
+              <a:spcAft>
+                <a:spcPts val="0"/>
+              </a:spcAft>
+            </a:pPr>
+            <a:r>
+              <a:rPr sz="2400" b="0">
+                <a:solidFill>
+                  <a:srgbClr val="304B53"/>
+                </a:solidFill>
+                <a:latin typeface="Liberation Sans"/>
+              </a:rPr>
+              <a:t>Job stays processing at version 2.</a:t>
+            </a:r>
+          </a:p>
+        </p:txBody>
+      </p:sp>
+      <p:sp>
+        <p:nvSpPr>
+          <p:cNvPr id="10" name="Text Try again: no new upload"/>
+          <p:cNvSpPr txBox="1"/>
+          <p:nvPr/>
+        </p:nvSpPr>
+        <p:spPr>
+          <a:xfrm>
+            <a:off x="5806440" y="3291840"/>
+            <a:ext cx="5577840" cy="429768"/>
+          </a:xfrm>
+          <a:prstGeom prst="rect">
+            <a:avLst/>
+          </a:prstGeom>
+          <a:noFill/>
+        </p:spPr>
+        <p:txBody>
+          <a:bodyPr wrap="square" lIns="9144" rIns="9144" tIns="0" bIns="0" anchor="t">
+            <a:spAutoFit/>
+          </a:bodyPr>
+          <a:lstStyle/>
+          <a:p>
+            <a:pPr>
+              <a:lnSpc>
+                <a:spcPct val="108000"/>
+              </a:lnSpc>
+              <a:spcBef>
+                <a:spcPts val="0"/>
+              </a:spcBef>
+              <a:spcAft>
+                <a:spcPts val="0"/>
+              </a:spcAft>
+            </a:pPr>
+            <a:r>
+              <a:rPr sz="2700" b="1">
+                <a:solidFill>
+                  <a:srgbClr val="008C91"/>
+                </a:solidFill>
+                <a:latin typeface="Liberation Sans"/>
+              </a:rPr>
+              <a:t>Try again: no new upload</a:t>
+            </a:r>
+          </a:p>
+        </p:txBody>
+      </p:sp>
+      <p:sp>
+        <p:nvSpPr>
+          <p:cNvPr id="11" name="Text Same job e8c3ad18…&#10;Network log: "/>
+          <p:cNvSpPr txBox="1"/>
+          <p:nvPr/>
+        </p:nvSpPr>
+        <p:spPr>
+          <a:xfrm>
+            <a:off x="5806440" y="3849624"/>
+            <a:ext cx="5577840" cy="777240"/>
+          </a:xfrm>
+          <a:prstGeom prst="rect">
+            <a:avLst/>
+          </a:prstGeom>
+          <a:noFill/>
+        </p:spPr>
+        <p:txBody>
+          <a:bodyPr wrap="square" lIns="9144" rIns="9144" tIns="0" bIns="0" anchor="t">
+            <a:spAutoFit/>
+          </a:bodyPr>
+          <a:lstStyle/>
+          <a:p>
+            <a:pPr>
+              <a:lnSpc>
+                <a:spcPct val="108000"/>
+              </a:lnSpc>
+              <a:spcBef>
+                <a:spcPts val="0"/>
+              </a:spcBef>
+              <a:spcAft>
+                <a:spcPts val="0"/>
+              </a:spcAft>
+            </a:pPr>
+            <a:r>
+              <a:rPr sz="2400" b="0">
+                <a:solidFill>
+                  <a:srgbClr val="304B53"/>
+                </a:solidFill>
+                <a:latin typeface="Liberation Sans"/>
+              </a:rPr>
+              <a:t>Same job e8c3ad18…</a:t>
+            </a:r>
+          </a:p>
+          <a:p>
+            <a:pPr>
+              <a:lnSpc>
+                <a:spcPct val="108000"/>
+              </a:lnSpc>
+              <a:spcBef>
+                <a:spcPts val="0"/>
+              </a:spcBef>
+              <a:spcAft>
+                <a:spcPts val="0"/>
+              </a:spcAft>
+            </a:pPr>
+            <a:r>
+              <a:rPr sz="2400" b="0">
+                <a:solidFill>
+                  <a:srgbClr val="304B53"/>
+                </a:solidFill>
+                <a:latin typeface="Liberation Sans"/>
+              </a:rPr>
+              <a:t>Network log: exactly 1 POST.</a:t>
+            </a:r>
+          </a:p>
+        </p:txBody>
+      </p:sp>
+      <p:sp>
+        <p:nvSpPr>
+          <p:cNvPr id="12" name="Text Same job completes"/>
+          <p:cNvSpPr txBox="1"/>
+          <p:nvPr/>
+        </p:nvSpPr>
+        <p:spPr>
+          <a:xfrm>
+            <a:off x="5806440" y="4754880"/>
+            <a:ext cx="5577840" cy="429768"/>
+          </a:xfrm>
+          <a:prstGeom prst="rect">
+            <a:avLst/>
+          </a:prstGeom>
+          <a:noFill/>
+        </p:spPr>
+        <p:txBody>
+          <a:bodyPr wrap="square" lIns="9144" rIns="9144" tIns="0" bIns="0" anchor="t">
+            <a:spAutoFit/>
+          </a:bodyPr>
+          <a:lstStyle/>
+          <a:p>
+            <a:pPr>
+              <a:lnSpc>
+                <a:spcPct val="108000"/>
+              </a:lnSpc>
+              <a:spcBef>
+                <a:spcPts val="0"/>
+              </a:spcBef>
+              <a:spcAft>
+                <a:spcPts val="0"/>
+              </a:spcAft>
+            </a:pPr>
+            <a:r>
+              <a:rPr sz="2700" b="1">
+                <a:solidFill>
+                  <a:srgbClr val="008C91"/>
+                </a:solidFill>
+                <a:latin typeface="Liberation Sans"/>
+              </a:rPr>
+              <a:t>Same job completes</a:t>
+            </a:r>
+          </a:p>
+        </p:txBody>
+      </p:sp>
+      <p:sp>
+        <p:nvSpPr>
+          <p:cNvPr id="13" name="Text Error clears; observation resume"/>
+          <p:cNvSpPr txBox="1"/>
+          <p:nvPr/>
+        </p:nvSpPr>
+        <p:spPr>
+          <a:xfrm>
+            <a:off x="5806440" y="5312664"/>
+            <a:ext cx="5577840" cy="777240"/>
+          </a:xfrm>
+          <a:prstGeom prst="rect">
+            <a:avLst/>
+          </a:prstGeom>
+          <a:noFill/>
+        </p:spPr>
+        <p:txBody>
+          <a:bodyPr wrap="square" lIns="9144" rIns="9144" tIns="0" bIns="0" anchor="t">
+            <a:spAutoFit/>
+          </a:bodyPr>
+          <a:lstStyle/>
+          <a:p>
+            <a:pPr>
+              <a:lnSpc>
+                <a:spcPct val="108000"/>
+              </a:lnSpc>
+              <a:spcBef>
+                <a:spcPts val="0"/>
+              </a:spcBef>
+              <a:spcAft>
+                <a:spcPts val="0"/>
+              </a:spcAft>
+            </a:pPr>
+            <a:r>
+              <a:rPr sz="2400" b="0">
+                <a:solidFill>
+                  <a:srgbClr val="304B53"/>
+                </a:solidFill>
+                <a:latin typeface="Liberation Sans"/>
+              </a:rPr>
+              <a:t>Error clears; observation resumes.</a:t>
+            </a:r>
+          </a:p>
+          <a:p>
+            <a:pPr>
+              <a:lnSpc>
+                <a:spcPct val="108000"/>
+              </a:lnSpc>
+              <a:spcBef>
+                <a:spcPts val="0"/>
+              </a:spcBef>
+              <a:spcAft>
+                <a:spcPts val="0"/>
+              </a:spcAft>
+            </a:pPr>
+            <a:r>
+              <a:rPr sz="2400" b="0">
+                <a:solidFill>
+                  <a:srgbClr val="304B53"/>
+                </a:solidFill>
+                <a:latin typeface="Liberation Sans"/>
+              </a:rPr>
+              <a:t>Retry checked in short polling.</a:t>
+            </a:r>
+          </a:p>
+        </p:txBody>
+      </p:sp>
+      <p:sp>
+        <p:nvSpPr>
+          <p:cNvPr id="14" name="Text Controlled fault: local forwarde"/>
+          <p:cNvSpPr txBox="1"/>
+          <p:nvPr/>
+        </p:nvSpPr>
+        <p:spPr>
+          <a:xfrm>
+            <a:off x="566928" y="6318504"/>
+            <a:ext cx="10972800" cy="201168"/>
+          </a:xfrm>
+          <a:prstGeom prst="rect">
+            <a:avLst/>
+          </a:prstGeom>
+          <a:noFill/>
+        </p:spPr>
+        <p:txBody>
+          <a:bodyPr wrap="square" lIns="9144" rIns="9144" tIns="0" bIns="0" anchor="t">
+            <a:spAutoFit/>
+          </a:bodyPr>
+          <a:lstStyle/>
+          <a:p>
+            <a:pPr>
+              <a:lnSpc>
+                <a:spcPct val="108000"/>
+              </a:lnSpc>
+              <a:spcBef>
+                <a:spcPts val="0"/>
+              </a:spcBef>
+              <a:spcAft>
+                <a:spcPts val="0"/>
+              </a:spcAft>
+            </a:pPr>
+            <a:r>
+              <a:rPr sz="1300" b="0">
+                <a:solidFill>
+                  <a:srgbClr val="62757A"/>
+                </a:solidFill>
+                <a:latin typeface="Liberation Sans"/>
+              </a:rPr>
+              <a:t>Controlled fault: local forwarder closes a status connection. Successful responses come from the real application.</a:t>
+            </a:r>
+          </a:p>
+        </p:txBody>
+      </p:sp>
+    </p:spTree>
+  </p:cSld>
+  <p:clrMapOvr>
+    <a:masterClrMapping/>
+  </p:clrMapOvr>
+</p:sld>
+</file>
+
+<file path=ppt/slides/slide15.xml><?xml version="1.0" encoding="utf-8"?>
+<p:sld xmlns:a="http://schemas.openxmlformats.org/drawingml/2006/main" xmlns:p="http://schemas.openxmlformats.org/presentationml/2006/main" xmlns:r="http://schemas.openxmlformats.org/officeDocument/2006/relationships">
+  <p:cSld>
+    <p:bg>
+      <p:bgPr>
+        <a:solidFill>
+          <a:srgbClr val="FFFFFF"/>
+        </a:solidFill>
+        <a:effectLst/>
+      </p:bgPr>
+    </p:bg>
+    <p:spTree>
+      <p:nvGrpSpPr>
+        <p:cNvPr id="1" name=""/>
+        <p:cNvGrpSpPr/>
+        <p:nvPr/>
+      </p:nvGrpSpPr>
+      <p:grpSpPr/>
+      <p:sp>
+        <p:nvSpPr>
+          <p:cNvPr id="2" name="Rectangle 1"/>
+          <p:cNvSpPr/>
+          <p:nvPr/>
+        </p:nvSpPr>
+        <p:spPr>
+          <a:xfrm>
+            <a:off x="475488" y="438912"/>
+            <a:ext cx="64008" cy="448056"/>
+          </a:xfrm>
+          <a:prstGeom prst="rect">
+            <a:avLst/>
+          </a:prstGeom>
+          <a:solidFill>
+            <a:srgbClr val="008C91"/>
+          </a:solidFill>
+          <a:ln>
+            <a:noFill/>
+          </a:ln>
+          <a:effectLst/>
+        </p:spPr>
+        <p:style>
+          <a:lnRef idx="1">
+            <a:schemeClr val="accent1"/>
+          </a:lnRef>
+          <a:fillRef idx="3">
+            <a:schemeClr val="accent1"/>
+          </a:fillRef>
+          <a:effectRef idx="2">
+            <a:schemeClr val="accent1"/>
+          </a:effectRef>
+          <a:fontRef idx="minor">
+            <a:schemeClr val="lt1"/>
+          </a:fontRef>
+        </p:style>
+        <p:txBody>
+          <a:bodyPr rtlCol="0" anchor="ctr"/>
+          <a:lstStyle/>
+          <a:p>
+            <a:pPr algn="ctr"/>
+          </a:p>
+        </p:txBody>
+      </p:sp>
+      <p:sp>
+        <p:nvSpPr>
+          <p:cNvPr id="3" name="Text Demonstration: failed jobs stop "/>
+          <p:cNvSpPr txBox="1"/>
+          <p:nvPr/>
+        </p:nvSpPr>
+        <p:spPr>
+          <a:xfrm>
+            <a:off x="694944" y="374904"/>
+            <a:ext cx="10972800" cy="521207"/>
+          </a:xfrm>
+          <a:prstGeom prst="rect">
+            <a:avLst/>
+          </a:prstGeom>
+          <a:noFill/>
+        </p:spPr>
+        <p:txBody>
+          <a:bodyPr wrap="square" lIns="9144" rIns="9144" tIns="0" bIns="0" anchor="t">
+            <a:spAutoFit/>
+          </a:bodyPr>
+          <a:lstStyle/>
+          <a:p>
+            <a:pPr>
+              <a:lnSpc>
+                <a:spcPct val="108000"/>
+              </a:lnSpc>
+              <a:spcBef>
+                <a:spcPts val="0"/>
+              </a:spcBef>
+              <a:spcAft>
+                <a:spcPts val="0"/>
+              </a:spcAft>
+            </a:pPr>
+            <a:r>
+              <a:rPr sz="3300" b="1">
+                <a:solidFill>
+                  <a:srgbClr val="17363D"/>
+                </a:solidFill>
+                <a:latin typeface="Liberation Sans"/>
+              </a:rPr>
+              <a:t>Demonstration: failed jobs stop polling</a:t>
+            </a:r>
+          </a:p>
+        </p:txBody>
+      </p:sp>
+      <p:sp>
+        <p:nvSpPr>
+          <p:cNvPr id="4" name="Text Daryn Forman  |  ImageLab Assess"/>
+          <p:cNvSpPr txBox="1"/>
+          <p:nvPr/>
+        </p:nvSpPr>
+        <p:spPr>
+          <a:xfrm>
+            <a:off x="521207" y="6537960"/>
+            <a:ext cx="8229600" cy="173736"/>
+          </a:xfrm>
+          <a:prstGeom prst="rect">
+            <a:avLst/>
+          </a:prstGeom>
+          <a:noFill/>
+        </p:spPr>
+        <p:txBody>
+          <a:bodyPr wrap="square" lIns="9144" rIns="9144" tIns="0" bIns="0" anchor="t">
+            <a:spAutoFit/>
+          </a:bodyPr>
+          <a:lstStyle/>
+          <a:p>
+            <a:pPr>
+              <a:lnSpc>
+                <a:spcPct val="108000"/>
+              </a:lnSpc>
+              <a:spcBef>
+                <a:spcPts val="0"/>
+              </a:spcBef>
+              <a:spcAft>
+                <a:spcPts val="0"/>
+              </a:spcAft>
+            </a:pPr>
+            <a:r>
+              <a:rPr sz="1100" b="0">
+                <a:solidFill>
+                  <a:srgbClr val="62757A"/>
+                </a:solidFill>
+                <a:latin typeface="Liberation Sans"/>
+              </a:rPr>
+              <a:t>Daryn Forman  |  ImageLab Assessment 2  |  Saved application evidence</a:t>
+            </a:r>
+          </a:p>
+        </p:txBody>
+      </p:sp>
+      <p:sp>
+        <p:nvSpPr>
+          <p:cNvPr id="5" name="Text 15"/>
+          <p:cNvSpPr txBox="1"/>
+          <p:nvPr/>
+        </p:nvSpPr>
+        <p:spPr>
+          <a:xfrm>
+            <a:off x="11082528" y="6492240"/>
+            <a:ext cx="576072" cy="228600"/>
+          </a:xfrm>
+          <a:prstGeom prst="rect">
+            <a:avLst/>
+          </a:prstGeom>
+          <a:noFill/>
+        </p:spPr>
+        <p:txBody>
+          <a:bodyPr wrap="square" lIns="9144" rIns="9144" tIns="0" bIns="0" anchor="t">
+            <a:spAutoFit/>
+          </a:bodyPr>
+          <a:lstStyle/>
+          <a:p>
+            <a:pPr algn="r">
+              <a:lnSpc>
+                <a:spcPct val="108000"/>
+              </a:lnSpc>
+              <a:spcBef>
+                <a:spcPts val="0"/>
+              </a:spcBef>
+              <a:spcAft>
+                <a:spcPts val="0"/>
+              </a:spcAft>
+            </a:pPr>
+            <a:r>
+              <a:rPr sz="1300" b="1">
+                <a:solidFill>
+                  <a:srgbClr val="008C91"/>
+                </a:solidFill>
+                <a:latin typeface="Liberation Sans"/>
+              </a:rPr>
+              <a:t>14</a:t>
+            </a:r>
+          </a:p>
+        </p:txBody>
+      </p:sp>
+      <p:sp>
+        <p:nvSpPr>
+          <p:cNvPr id="6" name="Text The real worker records failed; "/>
+          <p:cNvSpPr txBox="1"/>
+          <p:nvPr/>
+        </p:nvSpPr>
+        <p:spPr>
+          <a:xfrm>
+            <a:off x="548640" y="1051560"/>
+            <a:ext cx="11064240" cy="411480"/>
+          </a:xfrm>
+          <a:prstGeom prst="rect">
+            <a:avLst/>
+          </a:prstGeom>
+          <a:noFill/>
+        </p:spPr>
+        <p:txBody>
+          <a:bodyPr wrap="square" lIns="9144" rIns="9144" tIns="0" bIns="0" anchor="t">
+            <a:spAutoFit/>
+          </a:bodyPr>
+          <a:lstStyle/>
+          <a:p>
+            <a:pPr>
+              <a:lnSpc>
+                <a:spcPct val="108000"/>
+              </a:lnSpc>
+              <a:spcBef>
+                <a:spcPts val="0"/>
+              </a:spcBef>
+              <a:spcAft>
+                <a:spcPts val="0"/>
+              </a:spcAft>
+            </a:pPr>
+            <a:r>
+              <a:rPr sz="2400" b="0">
+                <a:solidFill>
+                  <a:srgbClr val="304B53"/>
+                </a:solidFill>
+                <a:latin typeface="Liberation Sans"/>
+              </a:rPr>
+              <a:t>The real worker records failed; the browser shows the error and stops.</a:t>
+            </a:r>
+          </a:p>
+        </p:txBody>
+      </p:sp>
+      <p:sp>
+        <p:nvSpPr>
+          <p:cNvPr id="7" name="Text Long polling"/>
+          <p:cNvSpPr txBox="1"/>
+          <p:nvPr/>
+        </p:nvSpPr>
+        <p:spPr>
+          <a:xfrm>
+            <a:off x="896112" y="1673352"/>
+            <a:ext cx="3566160" cy="384048"/>
+          </a:xfrm>
+          <a:prstGeom prst="rect">
+            <a:avLst/>
+          </a:prstGeom>
+          <a:noFill/>
+        </p:spPr>
+        <p:txBody>
+          <a:bodyPr wrap="square" lIns="9144" rIns="9144" tIns="0" bIns="0" anchor="t">
+            <a:spAutoFit/>
+          </a:bodyPr>
+          <a:lstStyle/>
+          <a:p>
+            <a:pPr>
+              <a:lnSpc>
+                <a:spcPct val="108000"/>
+              </a:lnSpc>
+              <a:spcBef>
+                <a:spcPts val="0"/>
+              </a:spcBef>
+              <a:spcAft>
+                <a:spcPts val="0"/>
+              </a:spcAft>
+            </a:pPr>
+            <a:r>
+              <a:rPr sz="2500" b="1">
+                <a:solidFill>
+                  <a:srgbClr val="008C91"/>
+                </a:solidFill>
+                <a:latin typeface="Liberation Sans"/>
+              </a:rPr>
+              <a:t>Long polling</a:t>
+            </a:r>
+          </a:p>
+        </p:txBody>
+      </p:sp>
+      <p:sp>
+        <p:nvSpPr>
+          <p:cNvPr id="8" name="Text Short polling"/>
+          <p:cNvSpPr txBox="1"/>
+          <p:nvPr/>
+        </p:nvSpPr>
+        <p:spPr>
+          <a:xfrm>
+            <a:off x="4736592" y="1673352"/>
+            <a:ext cx="3566160" cy="384048"/>
+          </a:xfrm>
+          <a:prstGeom prst="rect">
+            <a:avLst/>
+          </a:prstGeom>
+          <a:noFill/>
+        </p:spPr>
+        <p:txBody>
+          <a:bodyPr wrap="square" lIns="9144" rIns="9144" tIns="0" bIns="0" anchor="t">
+            <a:spAutoFit/>
+          </a:bodyPr>
+          <a:lstStyle/>
+          <a:p>
+            <a:pPr>
+              <a:lnSpc>
+                <a:spcPct val="108000"/>
+              </a:lnSpc>
+              <a:spcBef>
+                <a:spcPts val="0"/>
+              </a:spcBef>
+              <a:spcAft>
+                <a:spcPts val="0"/>
+              </a:spcAft>
+            </a:pPr>
+            <a:r>
+              <a:rPr sz="2500" b="1">
+                <a:solidFill>
+                  <a:srgbClr val="CF167E"/>
+                </a:solidFill>
+                <a:latin typeface="Liberation Sans"/>
+              </a:rPr>
+              <a:t>Short polling</a:t>
+            </a:r>
+          </a:p>
+        </p:txBody>
+      </p:sp>
+      <p:pic>
+        <p:nvPicPr>
+          <p:cNvPr id="9" name="Picture 8" descr="03-failure-long-presentation.gif"/>
+          <p:cNvPicPr>
+            <a:picLocks noChangeAspect="1"/>
+          </p:cNvPicPr>
+          <p:nvPr/>
+        </p:nvPicPr>
+        <p:blipFill>
+          <a:blip r:embed="rId2"/>
+          <a:stretch>
+            <a:fillRect/>
+          </a:stretch>
+        </p:blipFill>
+        <p:spPr>
+          <a:xfrm>
+            <a:off x="913041" y="2221992"/>
+            <a:ext cx="3203116" cy="3977639"/>
+          </a:xfrm>
+          <a:prstGeom prst="rect">
+            <a:avLst/>
+          </a:prstGeom>
+        </p:spPr>
+      </p:pic>
+      <p:pic>
+        <p:nvPicPr>
+          <p:cNvPr id="10" name="Picture 9" descr="04-failure-short-presentation.gif"/>
+          <p:cNvPicPr>
+            <a:picLocks noChangeAspect="1"/>
+          </p:cNvPicPr>
+          <p:nvPr/>
+        </p:nvPicPr>
+        <p:blipFill>
+          <a:blip r:embed="rId3"/>
+          <a:stretch>
+            <a:fillRect/>
+          </a:stretch>
+        </p:blipFill>
+        <p:spPr>
+          <a:xfrm>
+            <a:off x="4753521" y="2221992"/>
+            <a:ext cx="3203116" cy="3977639"/>
+          </a:xfrm>
+          <a:prstGeom prst="rect">
+            <a:avLst/>
+          </a:prstGeom>
+        </p:spPr>
+      </p:pic>
+      <p:sp>
+        <p:nvSpPr>
+          <p:cNvPr id="11" name="Text Safe error shown"/>
+          <p:cNvSpPr txBox="1"/>
+          <p:nvPr/>
+        </p:nvSpPr>
+        <p:spPr>
+          <a:xfrm>
+            <a:off x="8476488" y="2267712"/>
+            <a:ext cx="3163824" cy="768096"/>
+          </a:xfrm>
+          <a:prstGeom prst="rect">
+            <a:avLst/>
+          </a:prstGeom>
+          <a:noFill/>
+        </p:spPr>
+        <p:txBody>
+          <a:bodyPr wrap="square" lIns="9144" rIns="9144" tIns="0" bIns="0" anchor="t">
+            <a:spAutoFit/>
+          </a:bodyPr>
+          <a:lstStyle/>
+          <a:p>
+            <a:pPr>
+              <a:lnSpc>
+                <a:spcPct val="108000"/>
+              </a:lnSpc>
+              <a:spcBef>
+                <a:spcPts val="0"/>
+              </a:spcBef>
+              <a:spcAft>
+                <a:spcPts val="0"/>
+              </a:spcAft>
+            </a:pPr>
+            <a:r>
+              <a:rPr sz="2500" b="1">
+                <a:solidFill>
+                  <a:srgbClr val="008C91"/>
+                </a:solidFill>
+                <a:latin typeface="Liberation Sans"/>
+              </a:rPr>
+              <a:t>Safe error shown</a:t>
+            </a:r>
+          </a:p>
+        </p:txBody>
+      </p:sp>
+      <p:sp>
+        <p:nvSpPr>
+          <p:cNvPr id="12" name="Text No completed&#10;variant results"/>
+          <p:cNvSpPr txBox="1"/>
+          <p:nvPr/>
+        </p:nvSpPr>
+        <p:spPr>
+          <a:xfrm>
+            <a:off x="8476488" y="3273552"/>
+            <a:ext cx="3163824" cy="941832"/>
+          </a:xfrm>
+          <a:prstGeom prst="rect">
+            <a:avLst/>
+          </a:prstGeom>
+          <a:noFill/>
+        </p:spPr>
+        <p:txBody>
+          <a:bodyPr wrap="square" lIns="9144" rIns="9144" tIns="0" bIns="0" anchor="t">
+            <a:spAutoFit/>
+          </a:bodyPr>
+          <a:lstStyle/>
+          <a:p>
+            <a:pPr>
+              <a:lnSpc>
+                <a:spcPct val="108000"/>
+              </a:lnSpc>
+              <a:spcBef>
+                <a:spcPts val="0"/>
+              </a:spcBef>
+              <a:spcAft>
+                <a:spcPts val="0"/>
+              </a:spcAft>
+            </a:pPr>
+            <a:r>
+              <a:rPr sz="2400" b="0">
+                <a:solidFill>
+                  <a:srgbClr val="304B53"/>
+                </a:solidFill>
+                <a:latin typeface="Liberation Sans"/>
+              </a:rPr>
+              <a:t>No completed</a:t>
+            </a:r>
+          </a:p>
+          <a:p>
+            <a:pPr>
+              <a:lnSpc>
+                <a:spcPct val="108000"/>
+              </a:lnSpc>
+              <a:spcBef>
+                <a:spcPts val="0"/>
+              </a:spcBef>
+              <a:spcAft>
+                <a:spcPts val="0"/>
+              </a:spcAft>
+            </a:pPr>
+            <a:r>
+              <a:rPr sz="2400" b="0">
+                <a:solidFill>
+                  <a:srgbClr val="304B53"/>
+                </a:solidFill>
+                <a:latin typeface="Liberation Sans"/>
+              </a:rPr>
+              <a:t>variant results</a:t>
+            </a:r>
+          </a:p>
+        </p:txBody>
+      </p:sp>
+      <p:sp>
+        <p:nvSpPr>
+          <p:cNvPr id="13" name="Text No further GETs&#10;for over 6 secon"/>
+          <p:cNvSpPr txBox="1"/>
+          <p:nvPr/>
+        </p:nvSpPr>
+        <p:spPr>
+          <a:xfrm>
+            <a:off x="8476488" y="4471416"/>
+            <a:ext cx="3163824" cy="1042415"/>
+          </a:xfrm>
+          <a:prstGeom prst="rect">
+            <a:avLst/>
+          </a:prstGeom>
+          <a:noFill/>
+        </p:spPr>
+        <p:txBody>
+          <a:bodyPr wrap="square" lIns="9144" rIns="9144" tIns="0" bIns="0" anchor="t">
+            <a:spAutoFit/>
+          </a:bodyPr>
+          <a:lstStyle/>
+          <a:p>
+            <a:pPr>
+              <a:lnSpc>
+                <a:spcPct val="108000"/>
+              </a:lnSpc>
+              <a:spcBef>
+                <a:spcPts val="0"/>
+              </a:spcBef>
+              <a:spcAft>
+                <a:spcPts val="0"/>
+              </a:spcAft>
+            </a:pPr>
+            <a:r>
+              <a:rPr sz="2400" b="1">
+                <a:solidFill>
+                  <a:srgbClr val="17363D"/>
+                </a:solidFill>
+                <a:latin typeface="Liberation Sans"/>
+              </a:rPr>
+              <a:t>No further GETs</a:t>
+            </a:r>
+          </a:p>
+          <a:p>
+            <a:pPr>
+              <a:lnSpc>
+                <a:spcPct val="108000"/>
+              </a:lnSpc>
+              <a:spcBef>
+                <a:spcPts val="0"/>
+              </a:spcBef>
+              <a:spcAft>
+                <a:spcPts val="0"/>
+              </a:spcAft>
+            </a:pPr>
+            <a:r>
+              <a:rPr sz="2400" b="1">
+                <a:solidFill>
+                  <a:srgbClr val="17363D"/>
+                </a:solidFill>
+                <a:latin typeface="Liberation Sans"/>
+              </a:rPr>
+              <a:t>for over 6 seconds</a:t>
+            </a:r>
+          </a:p>
+          <a:p>
+            <a:pPr>
+              <a:lnSpc>
+                <a:spcPct val="108000"/>
+              </a:lnSpc>
+              <a:spcBef>
+                <a:spcPts val="0"/>
+              </a:spcBef>
+              <a:spcAft>
+                <a:spcPts val="0"/>
+              </a:spcAft>
+            </a:pPr>
+            <a:r>
+              <a:rPr sz="2400" b="1">
+                <a:solidFill>
+                  <a:srgbClr val="17363D"/>
+                </a:solidFill>
+                <a:latin typeface="Liberation Sans"/>
+              </a:rPr>
+              <a:t>in either mode</a:t>
+            </a:r>
+          </a:p>
+        </p:txBody>
+      </p:sp>
+      <p:sp>
+        <p:nvSpPr>
+          <p:cNvPr id="14" name="Text Fault setup: temporarily move on"/>
+          <p:cNvSpPr txBox="1"/>
+          <p:nvPr/>
+        </p:nvSpPr>
+        <p:spPr>
+          <a:xfrm>
+            <a:off x="566928" y="6318504"/>
+            <a:ext cx="10972800" cy="201168"/>
+          </a:xfrm>
+          <a:prstGeom prst="rect">
+            <a:avLst/>
+          </a:prstGeom>
+          <a:noFill/>
+        </p:spPr>
+        <p:txBody>
+          <a:bodyPr wrap="square" lIns="9144" rIns="9144" tIns="0" bIns="0" anchor="t">
+            <a:spAutoFit/>
+          </a:bodyPr>
+          <a:lstStyle/>
+          <a:p>
+            <a:pPr>
+              <a:lnSpc>
+                <a:spcPct val="108000"/>
+              </a:lnSpc>
+              <a:spcBef>
+                <a:spcPts val="0"/>
+              </a:spcBef>
+              <a:spcAft>
+                <a:spcPts val="0"/>
+              </a:spcAft>
+            </a:pPr>
+            <a:r>
+              <a:rPr sz="1300" b="0">
+                <a:solidFill>
+                  <a:srgbClr val="62757A"/>
+                </a:solidFill>
+                <a:latin typeface="Liberation Sans"/>
+              </a:rPr>
+              <a:t>Fault setup: temporarily move only each new demo upload copy; restore it after the worker records failure.</a:t>
             </a:r>
           </a:p>
         </p:txBody>

</xml_diff>